<commit_message>
Move the Entry Diagnostic QR onto the last slide of W00
The QR was on the repository front page. It belongs in the lecture instead:
it is scanned once, in the room, at the moment the class is asked to fill the
diagnostic in — not browsed from a landing page.

Slide 21 of W00 reproduces the deck's own chrome (accent rule, corner tags,
footer, page number) so it does not read as bolted on. The QR sits left at
3.55in with the short link printed beneath it, because a few phones never
scan and those students need to type it.

README now points at the W00 slide rather than carrying the link itself, and
the standalone QR card moved to instructor-private/ for printing.

W00 regenerated: 21 pages, one per slide.

Co-Authored-By: Claude Opus 5 (1M context) <noreply@anthropic.com>
</commit_message>
<xml_diff>
--- a/W00_The_biology_and_numbers_bridge.pptx
+++ b/W00_The_biology_and_numbers_bridge.pptx
@@ -25,6 +25,7 @@
     <p:sldId id="273" r:id="rId19"/>
     <p:sldId id="274" r:id="rId20"/>
     <p:sldId id="275" r:id="rId21"/>
+    <p:sldId id="276" r:id="rId27"/>
   </p:sldIdLst>
   <p:notesMasterIdLst>
     <p:notesMasterId r:id="rId22"/>
@@ -10309,6 +10310,10 @@
             <a:prstDash val="solid"/>
           </a:ln>
         </p:spPr>
+        <p:txBody>
+          <a:bodyPr/>
+          <a:p/>
+        </p:txBody>
       </p:sp>
       <p:sp>
         <p:nvSpPr>
@@ -10455,6 +10460,10 @@
             <a:prstDash val="solid"/>
           </a:ln>
         </p:spPr>
+        <p:txBody>
+          <a:bodyPr/>
+          <a:p/>
+        </p:txBody>
       </p:sp>
       <p:sp>
         <p:nvSpPr>
@@ -10599,6 +10608,458 @@
               <a:t>S10  DESeq2: Analyzing RNA-seq data with DESeq2, release vignette.</a:t>
             </a:r>
             <a:endParaRPr lang="en-US" sz="1997" dirty="0"/>
+          </a:p>
+        </p:txBody>
+      </p:sp>
+    </p:spTree>
+  </p:cSld>
+  <p:clrMapOvr>
+    <a:masterClrMapping/>
+  </p:clrMapOvr>
+</p:sld>
+</file>
+
+<file path=ppt/slides/slide21.xml><?xml version="1.0" encoding="utf-8"?>
+<p:sld xmlns:a="http://schemas.openxmlformats.org/drawingml/2006/main" xmlns:p="http://schemas.openxmlformats.org/presentationml/2006/main" xmlns:r="http://schemas.openxmlformats.org/officeDocument/2006/relationships">
+  <p:cSld>
+    <p:spTree>
+      <p:nvGrpSpPr>
+        <p:cNvPr id="1" name=""/>
+        <p:cNvGrpSpPr/>
+        <p:nvPr/>
+      </p:nvGrpSpPr>
+      <p:grpSpPr/>
+      <p:sp>
+        <p:nvSpPr>
+          <p:cNvPr id="2" name="Rectangle 1"/>
+          <p:cNvSpPr/>
+          <p:nvPr/>
+        </p:nvSpPr>
+        <p:spPr>
+          <a:xfrm>
+            <a:off x="0" y="0"/>
+            <a:ext cx="12188952" cy="82296"/>
+          </a:xfrm>
+          <a:prstGeom prst="rect">
+            <a:avLst/>
+          </a:prstGeom>
+          <a:solidFill>
+            <a:srgbClr val="2A78D6"/>
+          </a:solidFill>
+          <a:ln>
+            <a:noFill/>
+          </a:ln>
+          <a:effectLst/>
+        </p:spPr>
+        <p:style>
+          <a:lnRef idx="1">
+            <a:schemeClr val="accent1"/>
+          </a:lnRef>
+          <a:fillRef idx="3">
+            <a:schemeClr val="accent1"/>
+          </a:fillRef>
+          <a:effectRef idx="2">
+            <a:schemeClr val="accent1"/>
+          </a:effectRef>
+          <a:fontRef idx="minor">
+            <a:schemeClr val="lt1"/>
+          </a:fontRef>
+        </p:style>
+        <p:txBody>
+          <a:bodyPr rtlCol="0" anchor="ctr"/>
+          <a:lstStyle/>
+          <a:p>
+            <a:pPr algn="ctr"/>
+          </a:p>
+        </p:txBody>
+      </p:sp>
+      <p:sp>
+        <p:nvSpPr>
+          <p:cNvPr id="3" name="TextBox 2"/>
+          <p:cNvSpPr txBox="1"/>
+          <p:nvPr/>
+        </p:nvSpPr>
+        <p:spPr>
+          <a:xfrm>
+            <a:off x="502920" y="246888"/>
+            <a:ext cx="3657600" cy="292608"/>
+          </a:xfrm>
+          <a:prstGeom prst="rect">
+            <a:avLst/>
+          </a:prstGeom>
+          <a:noFill/>
+        </p:spPr>
+        <p:txBody>
+          <a:bodyPr wrap="square" lIns="0" rIns="0" tIns="0" bIns="0">
+            <a:spAutoFit/>
+          </a:bodyPr>
+          <a:lstStyle/>
+          <a:p>
+            <a:r>
+              <a:rPr sz="1000" b="1">
+                <a:solidFill>
+                  <a:srgbClr val="526171"/>
+                </a:solidFill>
+                <a:latin typeface="Aptos"/>
+              </a:rPr>
+              <a:t>BIB / BRIDGE</a:t>
+            </a:r>
+          </a:p>
+        </p:txBody>
+      </p:sp>
+      <p:sp>
+        <p:nvSpPr>
+          <p:cNvPr id="4" name="TextBox 3"/>
+          <p:cNvSpPr txBox="1"/>
+          <p:nvPr/>
+        </p:nvSpPr>
+        <p:spPr>
+          <a:xfrm>
+            <a:off x="9281160" y="246888"/>
+            <a:ext cx="2377440" cy="292608"/>
+          </a:xfrm>
+          <a:prstGeom prst="rect">
+            <a:avLst/>
+          </a:prstGeom>
+          <a:noFill/>
+        </p:spPr>
+        <p:txBody>
+          <a:bodyPr wrap="square" lIns="0" rIns="0" tIns="0" bIns="0">
+            <a:spAutoFit/>
+          </a:bodyPr>
+          <a:lstStyle/>
+          <a:p>
+            <a:pPr algn="r"/>
+            <a:r>
+              <a:rPr sz="1000" b="1">
+                <a:solidFill>
+                  <a:srgbClr val="2A78D6"/>
+                </a:solidFill>
+                <a:latin typeface="Aptos"/>
+              </a:rPr>
+              <a:t>ENTRY DIAGNOSTIC</a:t>
+            </a:r>
+          </a:p>
+        </p:txBody>
+      </p:sp>
+      <p:sp>
+        <p:nvSpPr>
+          <p:cNvPr id="5" name="TextBox 4"/>
+          <p:cNvSpPr txBox="1"/>
+          <p:nvPr/>
+        </p:nvSpPr>
+        <p:spPr>
+          <a:xfrm>
+            <a:off x="502920" y="786384"/>
+            <a:ext cx="11137392" cy="914400"/>
+          </a:xfrm>
+          <a:prstGeom prst="rect">
+            <a:avLst/>
+          </a:prstGeom>
+          <a:noFill/>
+        </p:spPr>
+        <p:txBody>
+          <a:bodyPr wrap="square" lIns="0" rIns="0" tIns="0" bIns="0" anchor="ctr">
+            <a:spAutoFit/>
+          </a:bodyPr>
+          <a:lstStyle/>
+          <a:p>
+            <a:r>
+              <a:rPr sz="3200" b="1">
+                <a:solidFill>
+                  <a:srgbClr val="232D3B"/>
+                </a:solidFill>
+                <a:latin typeface="Aptos"/>
+              </a:rPr>
+              <a:t>Before you leave: the Entry Diagnostic</a:t>
+            </a:r>
+          </a:p>
+        </p:txBody>
+      </p:sp>
+      <p:sp>
+        <p:nvSpPr>
+          <p:cNvPr id="6" name="Rectangle 5"/>
+          <p:cNvSpPr/>
+          <p:nvPr/>
+        </p:nvSpPr>
+        <p:spPr>
+          <a:xfrm>
+            <a:off x="502920" y="6355080"/>
+            <a:ext cx="11183112" cy="9144"/>
+          </a:xfrm>
+          <a:prstGeom prst="rect">
+            <a:avLst/>
+          </a:prstGeom>
+          <a:solidFill>
+            <a:srgbClr val="D8DEE6"/>
+          </a:solidFill>
+          <a:ln>
+            <a:noFill/>
+          </a:ln>
+          <a:effectLst/>
+        </p:spPr>
+        <p:style>
+          <a:lnRef idx="1">
+            <a:schemeClr val="accent1"/>
+          </a:lnRef>
+          <a:fillRef idx="3">
+            <a:schemeClr val="accent1"/>
+          </a:fillRef>
+          <a:effectRef idx="2">
+            <a:schemeClr val="accent1"/>
+          </a:effectRef>
+          <a:fontRef idx="minor">
+            <a:schemeClr val="lt1"/>
+          </a:fontRef>
+        </p:style>
+        <p:txBody>
+          <a:bodyPr rtlCol="0" anchor="ctr"/>
+          <a:lstStyle/>
+          <a:p>
+            <a:pPr algn="ctr"/>
+          </a:p>
+        </p:txBody>
+      </p:sp>
+      <p:sp>
+        <p:nvSpPr>
+          <p:cNvPr id="7" name="TextBox 6"/>
+          <p:cNvSpPr txBox="1"/>
+          <p:nvPr/>
+        </p:nvSpPr>
+        <p:spPr>
+          <a:xfrm>
+            <a:off x="502920" y="6473952"/>
+            <a:ext cx="5486400" cy="182880"/>
+          </a:xfrm>
+          <a:prstGeom prst="rect">
+            <a:avLst/>
+          </a:prstGeom>
+          <a:noFill/>
+        </p:spPr>
+        <p:txBody>
+          <a:bodyPr wrap="square" lIns="0" rIns="0" tIns="0" bIns="0">
+            <a:spAutoFit/>
+          </a:bodyPr>
+          <a:lstStyle/>
+          <a:p>
+            <a:r>
+              <a:rPr sz="800" b="0">
+                <a:solidFill>
+                  <a:srgbClr val="526171"/>
+                </a:solidFill>
+                <a:latin typeface="Aptos"/>
+              </a:rPr>
+              <a:t>BIOINFORMATICS FOR BIOENGINEERING</a:t>
+            </a:r>
+          </a:p>
+        </p:txBody>
+      </p:sp>
+      <p:sp>
+        <p:nvSpPr>
+          <p:cNvPr id="8" name="TextBox 7"/>
+          <p:cNvSpPr txBox="1"/>
+          <p:nvPr/>
+        </p:nvSpPr>
+        <p:spPr>
+          <a:xfrm>
+            <a:off x="7406640" y="6464808"/>
+            <a:ext cx="4251960" cy="210312"/>
+          </a:xfrm>
+          <a:prstGeom prst="rect">
+            <a:avLst/>
+          </a:prstGeom>
+          <a:noFill/>
+        </p:spPr>
+        <p:txBody>
+          <a:bodyPr wrap="square" lIns="0" rIns="0" tIns="0" bIns="0">
+            <a:spAutoFit/>
+          </a:bodyPr>
+          <a:lstStyle/>
+          <a:p>
+            <a:pPr algn="r"/>
+            <a:r>
+              <a:rPr sz="800" b="0">
+                <a:solidFill>
+                  <a:srgbClr val="526171"/>
+                </a:solidFill>
+                <a:latin typeface="Aptos"/>
+              </a:rPr>
+              <a:t>21</a:t>
+            </a:r>
+          </a:p>
+        </p:txBody>
+      </p:sp>
+      <p:pic>
+        <p:nvPicPr>
+          <p:cNvPr id="9" name="Picture 8" descr="qr_bare.png"/>
+          <p:cNvPicPr>
+            <a:picLocks noChangeAspect="1"/>
+          </p:cNvPicPr>
+          <p:nvPr/>
+        </p:nvPicPr>
+        <p:blipFill>
+          <a:blip r:embed="rId2"/>
+          <a:stretch>
+            <a:fillRect/>
+          </a:stretch>
+        </p:blipFill>
+        <p:spPr>
+          <a:xfrm>
+            <a:off x="960120" y="1965960"/>
+            <a:ext cx="3246120" cy="3246120"/>
+          </a:xfrm>
+          <a:prstGeom prst="rect">
+            <a:avLst/>
+          </a:prstGeom>
+        </p:spPr>
+      </p:pic>
+      <p:sp>
+        <p:nvSpPr>
+          <p:cNvPr id="10" name="TextBox 9"/>
+          <p:cNvSpPr txBox="1"/>
+          <p:nvPr/>
+        </p:nvSpPr>
+        <p:spPr>
+          <a:xfrm>
+            <a:off x="502920" y="5321808"/>
+            <a:ext cx="4160520" cy="292608"/>
+          </a:xfrm>
+          <a:prstGeom prst="rect">
+            <a:avLst/>
+          </a:prstGeom>
+          <a:noFill/>
+        </p:spPr>
+        <p:txBody>
+          <a:bodyPr wrap="square" lIns="0" rIns="0" tIns="0" bIns="0">
+            <a:spAutoFit/>
+          </a:bodyPr>
+          <a:lstStyle/>
+          <a:p>
+            <a:pPr algn="ctr"/>
+            <a:r>
+              <a:rPr sz="1400" b="1">
+                <a:solidFill>
+                  <a:srgbClr val="232D3B"/>
+                </a:solidFill>
+                <a:latin typeface="Aptos"/>
+              </a:rPr>
+              <a:t>https://forms.gle/8d7q8LGjdiRKuv3j8</a:t>
+            </a:r>
+          </a:p>
+        </p:txBody>
+      </p:sp>
+      <p:sp>
+        <p:nvSpPr>
+          <p:cNvPr id="11" name="TextBox 10"/>
+          <p:cNvSpPr txBox="1"/>
+          <p:nvPr/>
+        </p:nvSpPr>
+        <p:spPr>
+          <a:xfrm>
+            <a:off x="4846320" y="1965960"/>
+            <a:ext cx="6812280" cy="3566160"/>
+          </a:xfrm>
+          <a:prstGeom prst="rect">
+            <a:avLst/>
+          </a:prstGeom>
+          <a:noFill/>
+        </p:spPr>
+        <p:txBody>
+          <a:bodyPr wrap="square" lIns="0" rIns="0" tIns="0" bIns="0">
+            <a:spAutoFit/>
+          </a:bodyPr>
+          <a:lstStyle/>
+          <a:p>
+            <a:r>
+              <a:rPr sz="1600" b="0">
+                <a:solidFill>
+                  <a:srgbClr val="232D3B"/>
+                </a:solidFill>
+                <a:latin typeface="Aptos"/>
+              </a:rPr>
+              <a:t>Ungraded. It cannot affect your grade.</a:t>
+            </a:r>
+          </a:p>
+          <a:p>
+            <a:r>
+              <a:rPr sz="1600" b="0">
+                <a:solidFill>
+                  <a:srgbClr val="232D3B"/>
+                </a:solidFill>
+                <a:latin typeface="Aptos"/>
+              </a:rPr>
+              <a:t>About 15 minutes. No AI, no search, no notes.</a:t>
+            </a:r>
+          </a:p>
+          <a:p/>
+          <a:p>
+            <a:r>
+              <a:rPr sz="1600" b="0">
+                <a:solidFill>
+                  <a:srgbClr val="232D3B"/>
+                </a:solidFill>
+                <a:latin typeface="Aptos"/>
+              </a:rPr>
+              <a:t>Twelve questions, so I know which parts of this bridge to spend time on.</a:t>
+            </a:r>
+          </a:p>
+          <a:p/>
+          <a:p>
+            <a:r>
+              <a:rPr sz="1600" b="0">
+                <a:solidFill>
+                  <a:srgbClr val="232D3B"/>
+                </a:solidFill>
+                <a:latin typeface="Aptos"/>
+              </a:rPr>
+              <a:t>Choose “Not sure” rather than guessing. A confident wrong answer and an honest “not sure” need different help from me.</a:t>
+            </a:r>
+          </a:p>
+          <a:p/>
+          <a:p>
+            <a:r>
+              <a:rPr sz="1600" b="0">
+                <a:solidFill>
+                  <a:srgbClr val="232D3B"/>
+                </a:solidFill>
+                <a:latin typeface="Aptos"/>
+              </a:rPr>
+              <a:t>You get the answers and an explanation the moment you submit.</a:t>
+            </a:r>
+          </a:p>
+        </p:txBody>
+      </p:sp>
+      <p:sp>
+        <p:nvSpPr>
+          <p:cNvPr id="12" name="TextBox 11"/>
+          <p:cNvSpPr txBox="1"/>
+          <p:nvPr/>
+        </p:nvSpPr>
+        <p:spPr>
+          <a:xfrm>
+            <a:off x="4846320" y="5687568"/>
+            <a:ext cx="6812280" cy="502920"/>
+          </a:xfrm>
+          <a:prstGeom prst="rect">
+            <a:avLst/>
+          </a:prstGeom>
+          <a:noFill/>
+        </p:spPr>
+        <p:txBody>
+          <a:bodyPr wrap="square" lIns="0" rIns="0" tIns="0" bIns="0">
+            <a:spAutoFit/>
+          </a:bodyPr>
+          <a:lstStyle/>
+          <a:p>
+            <a:r>
+              <a:rPr sz="1300" b="0">
+                <a:solidFill>
+                  <a:srgbClr val="526171"/>
+                </a:solidFill>
+                <a:latin typeface="Aptos"/>
+              </a:rPr>
+              <a:t>Notlandırılmaz · Yaklaşık 15 dakika · Emin değilseniz tahmin etmek yerine “Emin değilim” seçin.</a:t>
+            </a:r>
           </a:p>
         </p:txBody>
       </p:sp>

</xml_diff>